<commit_message>
OYOP Alumni : signature Grégoire Giuliano, Délégué Alumni
Co-Authored-By: Claude Opus 5.5 <noreply@anthropic.com>
Claude-Session: https://claude.ai/code/session_01KaJpXuvUmXYvxNd2KYeiFj
</commit_message>
<xml_diff>
--- a/OYOP/OYOP_Alumni_2026-2027.pptx
+++ b/OYOP/OYOP_Alumni_2026-2027.pptx
@@ -5813,52 +5813,52 @@
           <a:p>
             <a:pPr algn="ctr"/>
             <a:r>
-              <a:rPr sz="1600" b="0" i="0">
-                <a:solidFill>
-                  <a:srgbClr val="2536B8"/>
-                </a:solidFill>
-                <a:latin typeface="Century Gothic"/>
-              </a:rPr>
-              <a:t>[NOM Prénom] - Délégué(e) Alumni</a:t>
-            </a:r>
-          </a:p>
-        </p:txBody>
-      </p:sp>
-      <p:sp>
-        <p:nvSpPr>
-          <p:cNvPr id="21" name="TextBox 20"/>
-          <p:cNvSpPr txBox="1"/>
-          <p:nvPr/>
-        </p:nvSpPr>
-        <p:spPr>
-          <a:xfrm>
-            <a:off x="868680" y="2743200"/>
-            <a:ext cx="3566160" cy="2560320"/>
-          </a:xfrm>
-          <a:prstGeom prst="rect">
-            <a:avLst/>
-          </a:prstGeom>
-          <a:noFill/>
-        </p:spPr>
-        <p:txBody>
-          <a:bodyPr wrap="square" anchor="t" lIns="0" rIns="0" tIns="0" bIns="0">
-            <a:spAutoFit/>
-          </a:bodyPr>
-          <a:lstStyle/>
-          <a:p>
-            <a:pPr algn="l">
-              <a:spcAft>
-                <a:spcPts val="200"/>
-              </a:spcAft>
-            </a:pPr>
-            <a:r>
               <a:rPr sz="1400" b="0" i="0">
                 <a:solidFill>
                   <a:srgbClr val="2536B8"/>
                 </a:solidFill>
                 <a:latin typeface="Century Gothic"/>
               </a:rPr>
-              <a:t>Seul·e en charge de la délégation, en lien direct avec le Board et la Présidence.</a:t>
+              <a:t>GIULIANO Grégoire - Délégué Alumni</a:t>
+            </a:r>
+          </a:p>
+        </p:txBody>
+      </p:sp>
+      <p:sp>
+        <p:nvSpPr>
+          <p:cNvPr id="21" name="TextBox 20"/>
+          <p:cNvSpPr txBox="1"/>
+          <p:nvPr/>
+        </p:nvSpPr>
+        <p:spPr>
+          <a:xfrm>
+            <a:off x="868680" y="2743200"/>
+            <a:ext cx="3566160" cy="2560320"/>
+          </a:xfrm>
+          <a:prstGeom prst="rect">
+            <a:avLst/>
+          </a:prstGeom>
+          <a:noFill/>
+        </p:spPr>
+        <p:txBody>
+          <a:bodyPr wrap="square" anchor="t" lIns="0" rIns="0" tIns="0" bIns="0">
+            <a:spAutoFit/>
+          </a:bodyPr>
+          <a:lstStyle/>
+          <a:p>
+            <a:pPr algn="l">
+              <a:spcAft>
+                <a:spcPts val="200"/>
+              </a:spcAft>
+            </a:pPr>
+            <a:r>
+              <a:rPr sz="1400" b="0" i="0">
+                <a:solidFill>
+                  <a:srgbClr val="2536B8"/>
+                </a:solidFill>
+                <a:latin typeface="Century Gothic"/>
+              </a:rPr>
+              <a:t>Seul en charge de la délégation, en lien direct avec le Board et la Présidence.</a:t>
             </a:r>
           </a:p>
           <a:p>
@@ -5890,7 +5890,7 @@
                 </a:solidFill>
                 <a:latin typeface="Century Gothic"/>
               </a:rPr>
-              <a:t>Interlocuteur·rice unique des anciens membres d’ELSA Louvain-La-Neuve.</a:t>
+              <a:t>Interlocuteur unique des anciens membres d’ELSA Louvain-La-Neuve.</a:t>
             </a:r>
           </a:p>
         </p:txBody>
@@ -11185,7 +11185,7 @@
                 </a:solidFill>
                 <a:latin typeface="Century Gothic"/>
               </a:rPr>
-              <a:t>[Prénom NOM] - Délégué(e) Alumni</a:t>
+              <a:t>Grégoire Giuliano - Délégué Alumni</a:t>
             </a:r>
           </a:p>
         </p:txBody>

</xml_diff>